<commit_message>
Deploying to gh-pages from @ nlmixr2/monolix2rx@4cd9f9c12714782320e60310b0b38407347c17c8 🚀
</commit_message>
<xml_diff>
--- a/articles/mod-PowerPoint.pptx
+++ b/articles/mod-PowerPoint.pptx
@@ -15,6 +15,8 @@
     <p:sldId id="257" r:id="rId9"/>
     <p:sldId id="258" r:id="rId10"/>
     <p:sldId id="259" r:id="rId11"/>
+    <p:sldId id="260" r:id="rId12"/>
+    <p:sldId id="261" r:id="rId13"/>
   </p:sldIdLst>
   <p:sldSz cx="12192000" cy="6858000"/>
   <p:notesSz cx="6858000" cy="9144000"/>
@@ -3650,6 +3652,1140 @@
           <a:p>
             <a:r>
               <a:rPr/>
+              <a:t>Model structure</a:t>
+            </a:r>
+          </a:p>
+        </p:txBody>
+      </p:sp>
+      <p:pic>
+        <p:nvPicPr>
+          <p:cNvPr id="3" name="Text Placeholder 2" descr=""/>
+          <p:cNvPicPr>
+            <a:picLocks noGrp="1"/>
+          </p:cNvPicPr>
+          <p:nvPr>
+            <p:ph idx="1"/>
+          </p:nvPr>
+        </p:nvPicPr>
+        <p:blipFill>
+          <a:blip r:embed="rId2"/>
+          <a:stretch>
+            <a:fillRect/>
+          </a:stretch>
+        </p:blipFill>
+        <p:spPr>
+          <a:xfrm>
+            <a:off x="623392" y="1196752"/>
+            <a:ext cx="10945216" cy="5184576"/>
+          </a:xfrm>
+          <a:prstGeom prst="rect">
+            <a:avLst/>
+          </a:prstGeom>
+        </p:spPr>
+      </p:pic>
+    </p:spTree>
+  </p:cSld>
+  <p:clrMapOvr>
+    <a:masterClrMapping/>
+  </p:clrMapOvr>
+</p:sld>
+</file>
+
+<file path=ppt/slides/slide2.xml><?xml version="1.0" encoding="utf-8"?>
+<p:sld xmlns:a="http://schemas.openxmlformats.org/drawingml/2006/main" xmlns:r="http://schemas.openxmlformats.org/officeDocument/2006/relationships" xmlns:p="http://schemas.openxmlformats.org/presentationml/2006/main">
+  <p:cSld>
+    <p:spTree>
+      <p:nvGrpSpPr>
+        <p:cNvPr id="1" name=""/>
+        <p:cNvGrpSpPr/>
+        <p:nvPr/>
+      </p:nvGrpSpPr>
+      <p:grpSpPr>
+        <a:xfrm>
+          <a:off x="0" y="0"/>
+          <a:ext cx="0" cy="0"/>
+          <a:chOff x="0" y="0"/>
+          <a:chExt cx="0" cy="0"/>
+        </a:xfrm>
+      </p:grpSpPr>
+      <p:sp>
+        <p:nvSpPr>
+          <p:cNvPr id="2" name="Title 1"/>
+          <p:cNvSpPr>
+            <a:spLocks noGrp="1"/>
+          </p:cNvSpPr>
+          <p:nvPr>
+            <p:ph type="title"/>
+          </p:nvPr>
+        </p:nvSpPr>
+        <p:spPr>
+          <a:xfrm>
+            <a:off x="623392" y="113388"/>
+            <a:ext cx="10945216" cy="985909"/>
+          </a:xfrm>
+        </p:spPr>
+        <p:txBody>
+          <a:bodyPr/>
+          <a:lstStyle/>
+          <a:p>
+            <a:r>
+              <a:rPr/>
+              <a:t>Model equations</a:t>
+            </a:r>
+          </a:p>
+        </p:txBody>
+      </p:sp>
+      <p:graphicFrame>
+        <p:nvGraphicFramePr>
+          <p:cNvPr id="3" name="Text Placeholder 2"/>
+          <p:cNvGraphicFramePr>
+            <a:graphicFrameLocks noGrp="true"/>
+          </p:cNvGraphicFramePr>
+          <p:nvPr/>
+        </p:nvGraphicFramePr>
+        <p:xfrm rot="0">
+          <a:off x="623392" y="1196752"/>
+          <a:ext cx="10945216" cy="5184576"/>
+        </p:xfrm>
+        <a:graphic>
+          <a:graphicData uri="http://schemas.openxmlformats.org/drawingml/2006/table">
+            <a:tbl>
+              <a:tblPr/>
+              <a:tblGrid>
+                <a:gridCol w="5486400"/>
+              </a:tblGrid>
+              <a:tr h="228600">
+                <a:tc>
+                  <a:txBody>
+                    <a:bodyPr/>
+                    <a:lstStyle/>
+                    <a:p>
+                      <a:pPr algn="l" marL="63500" marR="63500">
+                        <a:lnSpc>
+                          <a:spcPct val="100000"/>
+                        </a:lnSpc>
+                        <a:spcBef>
+                          <a:spcPts val="100"/>
+                        </a:spcBef>
+                        <a:spcAft>
+                          <a:spcPts val="100"/>
+                        </a:spcAft>
+                        <a:buNone/>
+                      </a:pPr>
+                      <a:rPr cap="none" sz="1100" i="0" b="0" u="none" strike="noStrike">
+                        <a:solidFill>
+                          <a:srgbClr val="000000">
+                            <a:alpha val="100000"/>
+                          </a:srgbClr>
+                        </a:solidFill>
+                        <a:latin typeface="DejaVu Sans"/>
+                        <a:cs typeface="DejaVu Sans"/>
+                        <a:ea typeface="DejaVu Sans"/>
+                        <a:sym typeface="DejaVu Sans"/>
+                      </a:rPr>
+                      <mc:AlternateContent xmlns:mc="http://schemas.openxmlformats.org/markup-compatibility/2006">
+                        <mc:Choice xmlns:a14="http://schemas.microsoft.com/office/drawing/2010/main" Requires="a14">
+                          <a14:m>
+                            <m:oMathPara xmlns:m="http://schemas.openxmlformats.org/officeDocument/2006/math">
+                              <m:oMathParaPr>
+                                <m:jc m:val="centerGroup"/>
+                              </m:oMathParaPr>
+                              <m:oMath xmlns:mml="http://www.w3.org/1998/Math/MathML">
+                                <m:r>
+                                  <m:t>cmt(</m:t>
+                                </m:r>
+                                <m:r>
+                                  <m:t>depot</m:t>
+                                </m:r>
+                                <m:r>
+                                  <m:t>)</m:t>
+                                </m:r>
+                              </m:oMath>
+                            </m:oMathPara>
+                          </a14:m>
+                        </mc:Choice>
+                      </mc:AlternateContent>
+                    </a:p>
+                  </a:txBody>
+                  <a:tcPr anchor="ctr" marB="12700" marT="12700" marR="0" marL="0">
+                    <a:lnL algn="ctr" cmpd="sng" cap="flat" w="0">
+                      <a:noFill/>
+                      <a:prstDash val="solid"/>
+                    </a:lnL>
+                    <a:lnR algn="ctr" cmpd="sng" cap="flat" w="0">
+                      <a:noFill/>
+                      <a:prstDash val="solid"/>
+                    </a:lnR>
+                    <a:lnT algn="ctr" cmpd="sng" cap="flat" w="0">
+                      <a:noFill/>
+                      <a:prstDash val="solid"/>
+                    </a:lnT>
+                    <a:lnB algn="ctr" cmpd="sng" cap="flat" w="0">
+                      <a:noFill/>
+                      <a:prstDash val="solid"/>
+                    </a:lnB>
+                    <a:solidFill>
+                      <a:srgbClr val="FFFFFF">
+                        <a:alpha val="0"/>
+                      </a:srgbClr>
+                    </a:solidFill>
+                  </a:tcPr>
+                </a:tc>
+              </a:tr>
+              <a:tr h="228600">
+                <a:tc>
+                  <a:txBody>
+                    <a:bodyPr/>
+                    <a:lstStyle/>
+                    <a:p>
+                      <a:pPr algn="l" marL="63500" marR="63500">
+                        <a:lnSpc>
+                          <a:spcPct val="100000"/>
+                        </a:lnSpc>
+                        <a:spcBef>
+                          <a:spcPts val="100"/>
+                        </a:spcBef>
+                        <a:spcAft>
+                          <a:spcPts val="100"/>
+                        </a:spcAft>
+                        <a:buNone/>
+                      </a:pPr>
+                      <a:rPr cap="none" sz="1100" i="0" b="0" u="none" strike="noStrike">
+                        <a:solidFill>
+                          <a:srgbClr val="000000">
+                            <a:alpha val="100000"/>
+                          </a:srgbClr>
+                        </a:solidFill>
+                        <a:latin typeface="DejaVu Sans"/>
+                        <a:cs typeface="DejaVu Sans"/>
+                        <a:ea typeface="DejaVu Sans"/>
+                        <a:sym typeface="DejaVu Sans"/>
+                      </a:rPr>
+                      <mc:AlternateContent xmlns:mc="http://schemas.openxmlformats.org/markup-compatibility/2006">
+                        <mc:Choice xmlns:a14="http://schemas.microsoft.com/office/drawing/2010/main" Requires="a14">
+                          <a14:m>
+                            <m:oMathPara xmlns:m="http://schemas.openxmlformats.org/officeDocument/2006/math">
+                              <m:oMathParaPr>
+                                <m:jc m:val="centerGroup"/>
+                              </m:oMathParaPr>
+                              <m:oMath xmlns:mml="http://www.w3.org/1998/Math/MathML">
+                                <m:r>
+                                  <m:t>cmt(</m:t>
+                                </m:r>
+                                <m:r>
+                                  <m:t>central</m:t>
+                                </m:r>
+                                <m:r>
+                                  <m:t>)</m:t>
+                                </m:r>
+                              </m:oMath>
+                            </m:oMathPara>
+                          </a14:m>
+                        </mc:Choice>
+                      </mc:AlternateContent>
+                    </a:p>
+                  </a:txBody>
+                  <a:tcPr anchor="ctr" marB="12700" marT="12700" marR="0" marL="0">
+                    <a:lnL algn="ctr" cmpd="sng" cap="flat" w="0">
+                      <a:noFill/>
+                      <a:prstDash val="solid"/>
+                    </a:lnL>
+                    <a:lnR algn="ctr" cmpd="sng" cap="flat" w="0">
+                      <a:noFill/>
+                      <a:prstDash val="solid"/>
+                    </a:lnR>
+                    <a:lnT algn="ctr" cmpd="sng" cap="flat" w="0">
+                      <a:noFill/>
+                      <a:prstDash val="solid"/>
+                    </a:lnT>
+                    <a:lnB algn="ctr" cmpd="sng" cap="flat" w="0">
+                      <a:noFill/>
+                      <a:prstDash val="solid"/>
+                    </a:lnB>
+                    <a:solidFill>
+                      <a:srgbClr val="FFFFFF">
+                        <a:alpha val="0"/>
+                      </a:srgbClr>
+                    </a:solidFill>
+                  </a:tcPr>
+                </a:tc>
+              </a:tr>
+              <a:tr h="228600">
+                <a:tc>
+                  <a:txBody>
+                    <a:bodyPr/>
+                    <a:lstStyle/>
+                    <a:p>
+                      <a:pPr algn="l" marL="63500" marR="63500">
+                        <a:lnSpc>
+                          <a:spcPct val="100000"/>
+                        </a:lnSpc>
+                        <a:spcBef>
+                          <a:spcPts val="100"/>
+                        </a:spcBef>
+                        <a:spcAft>
+                          <a:spcPts val="100"/>
+                        </a:spcAft>
+                        <a:buNone/>
+                      </a:pPr>
+                      <a:rPr cap="none" sz="1100" i="0" b="0" u="none" strike="noStrike">
+                        <a:solidFill>
+                          <a:srgbClr val="000000">
+                            <a:alpha val="100000"/>
+                          </a:srgbClr>
+                        </a:solidFill>
+                        <a:latin typeface="DejaVu Sans"/>
+                        <a:cs typeface="DejaVu Sans"/>
+                        <a:ea typeface="DejaVu Sans"/>
+                        <a:sym typeface="DejaVu Sans"/>
+                      </a:rPr>
+                      <mc:AlternateContent xmlns:mc="http://schemas.openxmlformats.org/markup-compatibility/2006">
+                        <mc:Choice xmlns:a14="http://schemas.microsoft.com/office/drawing/2010/main" Requires="a14">
+                          <a14:m>
+                            <m:oMathPara xmlns:m="http://schemas.openxmlformats.org/officeDocument/2006/math">
+                              <m:oMathParaPr>
+                                <m:jc m:val="centerGroup"/>
+                              </m:oMathParaPr>
+                              <m:oMath xmlns:mml="http://www.w3.org/1998/Math/MathML">
+                                <m:r>
+                                  <m:t>ka</m:t>
+                                </m:r>
+                                <m:r>
+                                  <m:t>=</m:t>
+                                </m:r>
+                                <m:r>
+                                  <m:rPr>
+                                    <m:sty m:val="p"/>
+                                  </m:rPr>
+                                  <m:t>exp</m:t>
+                                </m:r>
+                                <m:r>
+                                  <m:t>⁡</m:t>
+                                </m:r>
+                                <m:r>
+                                  <m:t>(</m:t>
+                                </m:r>
+                                <m:r>
+                                  <m:t>ka</m:t>
+                                </m:r>
+                                <m:r>
+                                  <m:rPr>
+                                    <m:sty m:val="p"/>
+                                  </m:rPr>
+                                  <m:t>_</m:t>
+                                </m:r>
+                                <m:r>
+                                  <m:t>pop</m:t>
+                                </m:r>
+                                <m:r>
+                                  <m:t>+</m:t>
+                                </m:r>
+                                <m:r>
+                                  <m:t>omega</m:t>
+                                </m:r>
+                                <m:r>
+                                  <m:rPr>
+                                    <m:sty m:val="p"/>
+                                  </m:rPr>
+                                  <m:t>_</m:t>
+                                </m:r>
+                                <m:r>
+                                  <m:t>ka</m:t>
+                                </m:r>
+                                <m:r>
+                                  <m:t>)</m:t>
+                                </m:r>
+                              </m:oMath>
+                            </m:oMathPara>
+                          </a14:m>
+                        </mc:Choice>
+                      </mc:AlternateContent>
+                    </a:p>
+                  </a:txBody>
+                  <a:tcPr anchor="ctr" marB="12700" marT="12700" marR="0" marL="0">
+                    <a:lnL algn="ctr" cmpd="sng" cap="flat" w="0">
+                      <a:noFill/>
+                      <a:prstDash val="solid"/>
+                    </a:lnL>
+                    <a:lnR algn="ctr" cmpd="sng" cap="flat" w="0">
+                      <a:noFill/>
+                      <a:prstDash val="solid"/>
+                    </a:lnR>
+                    <a:lnT algn="ctr" cmpd="sng" cap="flat" w="0">
+                      <a:noFill/>
+                      <a:prstDash val="solid"/>
+                    </a:lnT>
+                    <a:lnB algn="ctr" cmpd="sng" cap="flat" w="0">
+                      <a:noFill/>
+                      <a:prstDash val="solid"/>
+                    </a:lnB>
+                    <a:solidFill>
+                      <a:srgbClr val="FFFFFF">
+                        <a:alpha val="0"/>
+                      </a:srgbClr>
+                    </a:solidFill>
+                  </a:tcPr>
+                </a:tc>
+              </a:tr>
+              <a:tr h="228600">
+                <a:tc>
+                  <a:txBody>
+                    <a:bodyPr/>
+                    <a:lstStyle/>
+                    <a:p>
+                      <a:pPr algn="l" marL="63500" marR="63500">
+                        <a:lnSpc>
+                          <a:spcPct val="100000"/>
+                        </a:lnSpc>
+                        <a:spcBef>
+                          <a:spcPts val="100"/>
+                        </a:spcBef>
+                        <a:spcAft>
+                          <a:spcPts val="100"/>
+                        </a:spcAft>
+                        <a:buNone/>
+                      </a:pPr>
+                      <a:rPr cap="none" sz="1100" i="0" b="0" u="none" strike="noStrike">
+                        <a:solidFill>
+                          <a:srgbClr val="000000">
+                            <a:alpha val="100000"/>
+                          </a:srgbClr>
+                        </a:solidFill>
+                        <a:latin typeface="DejaVu Sans"/>
+                        <a:cs typeface="DejaVu Sans"/>
+                        <a:ea typeface="DejaVu Sans"/>
+                        <a:sym typeface="DejaVu Sans"/>
+                      </a:rPr>
+                      <mc:AlternateContent xmlns:mc="http://schemas.openxmlformats.org/markup-compatibility/2006">
+                        <mc:Choice xmlns:a14="http://schemas.microsoft.com/office/drawing/2010/main" Requires="a14">
+                          <a14:m>
+                            <m:oMathPara xmlns:m="http://schemas.openxmlformats.org/officeDocument/2006/math">
+                              <m:oMathParaPr>
+                                <m:jc m:val="centerGroup"/>
+                              </m:oMathParaPr>
+                              <m:oMath xmlns:mml="http://www.w3.org/1998/Math/MathML">
+                                <m:r>
+                                  <m:t>V=</m:t>
+                                </m:r>
+                                <m:r>
+                                  <m:rPr>
+                                    <m:sty m:val="p"/>
+                                  </m:rPr>
+                                  <m:t>exp</m:t>
+                                </m:r>
+                                <m:r>
+                                  <m:t>⁡</m:t>
+                                </m:r>
+                                <m:r>
+                                  <m:t>(</m:t>
+                                </m:r>
+                                <m:r>
+                                  <m:t>V</m:t>
+                                </m:r>
+                                <m:r>
+                                  <m:rPr>
+                                    <m:sty m:val="p"/>
+                                  </m:rPr>
+                                  <m:t>_</m:t>
+                                </m:r>
+                                <m:r>
+                                  <m:t>pop</m:t>
+                                </m:r>
+                                <m:r>
+                                  <m:t>+</m:t>
+                                </m:r>
+                                <m:r>
+                                  <m:t>omega</m:t>
+                                </m:r>
+                                <m:r>
+                                  <m:rPr>
+                                    <m:sty m:val="p"/>
+                                  </m:rPr>
+                                  <m:t>_</m:t>
+                                </m:r>
+                                <m:r>
+                                  <m:t>V</m:t>
+                                </m:r>
+                                <m:r>
+                                  <m:t>)</m:t>
+                                </m:r>
+                              </m:oMath>
+                            </m:oMathPara>
+                          </a14:m>
+                        </mc:Choice>
+                      </mc:AlternateContent>
+                    </a:p>
+                  </a:txBody>
+                  <a:tcPr anchor="ctr" marB="12700" marT="12700" marR="0" marL="0">
+                    <a:lnL algn="ctr" cmpd="sng" cap="flat" w="0">
+                      <a:noFill/>
+                      <a:prstDash val="solid"/>
+                    </a:lnL>
+                    <a:lnR algn="ctr" cmpd="sng" cap="flat" w="0">
+                      <a:noFill/>
+                      <a:prstDash val="solid"/>
+                    </a:lnR>
+                    <a:lnT algn="ctr" cmpd="sng" cap="flat" w="0">
+                      <a:noFill/>
+                      <a:prstDash val="solid"/>
+                    </a:lnT>
+                    <a:lnB algn="ctr" cmpd="sng" cap="flat" w="0">
+                      <a:noFill/>
+                      <a:prstDash val="solid"/>
+                    </a:lnB>
+                    <a:solidFill>
+                      <a:srgbClr val="FFFFFF">
+                        <a:alpha val="0"/>
+                      </a:srgbClr>
+                    </a:solidFill>
+                  </a:tcPr>
+                </a:tc>
+              </a:tr>
+              <a:tr h="228600">
+                <a:tc>
+                  <a:txBody>
+                    <a:bodyPr/>
+                    <a:lstStyle/>
+                    <a:p>
+                      <a:pPr algn="l" marL="63500" marR="63500">
+                        <a:lnSpc>
+                          <a:spcPct val="100000"/>
+                        </a:lnSpc>
+                        <a:spcBef>
+                          <a:spcPts val="100"/>
+                        </a:spcBef>
+                        <a:spcAft>
+                          <a:spcPts val="100"/>
+                        </a:spcAft>
+                        <a:buNone/>
+                      </a:pPr>
+                      <a:rPr cap="none" sz="1100" i="0" b="0" u="none" strike="noStrike">
+                        <a:solidFill>
+                          <a:srgbClr val="000000">
+                            <a:alpha val="100000"/>
+                          </a:srgbClr>
+                        </a:solidFill>
+                        <a:latin typeface="DejaVu Sans"/>
+                        <a:cs typeface="DejaVu Sans"/>
+                        <a:ea typeface="DejaVu Sans"/>
+                        <a:sym typeface="DejaVu Sans"/>
+                      </a:rPr>
+                      <mc:AlternateContent xmlns:mc="http://schemas.openxmlformats.org/markup-compatibility/2006">
+                        <mc:Choice xmlns:a14="http://schemas.microsoft.com/office/drawing/2010/main" Requires="a14">
+                          <a14:m>
+                            <m:oMathPara xmlns:m="http://schemas.openxmlformats.org/officeDocument/2006/math">
+                              <m:oMathParaPr>
+                                <m:jc m:val="centerGroup"/>
+                              </m:oMathParaPr>
+                              <m:oMath xmlns:mml="http://www.w3.org/1998/Math/MathML">
+                                <m:r>
+                                  <m:t>Cl</m:t>
+                                </m:r>
+                                <m:r>
+                                  <m:t>=</m:t>
+                                </m:r>
+                                <m:r>
+                                  <m:rPr>
+                                    <m:sty m:val="p"/>
+                                  </m:rPr>
+                                  <m:t>exp</m:t>
+                                </m:r>
+                                <m:r>
+                                  <m:t>⁡</m:t>
+                                </m:r>
+                                <m:r>
+                                  <m:t>(</m:t>
+                                </m:r>
+                                <m:r>
+                                  <m:t>Cl</m:t>
+                                </m:r>
+                                <m:r>
+                                  <m:rPr>
+                                    <m:sty m:val="p"/>
+                                  </m:rPr>
+                                  <m:t>_</m:t>
+                                </m:r>
+                                <m:r>
+                                  <m:t>pop</m:t>
+                                </m:r>
+                                <m:r>
+                                  <m:t>+</m:t>
+                                </m:r>
+                                <m:r>
+                                  <m:t>omega</m:t>
+                                </m:r>
+                                <m:r>
+                                  <m:rPr>
+                                    <m:sty m:val="p"/>
+                                  </m:rPr>
+                                  <m:t>_</m:t>
+                                </m:r>
+                                <m:r>
+                                  <m:t>Cl</m:t>
+                                </m:r>
+                                <m:r>
+                                  <m:t>)</m:t>
+                                </m:r>
+                              </m:oMath>
+                            </m:oMathPara>
+                          </a14:m>
+                        </mc:Choice>
+                      </mc:AlternateContent>
+                    </a:p>
+                  </a:txBody>
+                  <a:tcPr anchor="ctr" marB="12700" marT="12700" marR="0" marL="0">
+                    <a:lnL algn="ctr" cmpd="sng" cap="flat" w="0">
+                      <a:noFill/>
+                      <a:prstDash val="solid"/>
+                    </a:lnL>
+                    <a:lnR algn="ctr" cmpd="sng" cap="flat" w="0">
+                      <a:noFill/>
+                      <a:prstDash val="solid"/>
+                    </a:lnR>
+                    <a:lnT algn="ctr" cmpd="sng" cap="flat" w="0">
+                      <a:noFill/>
+                      <a:prstDash val="solid"/>
+                    </a:lnT>
+                    <a:lnB algn="ctr" cmpd="sng" cap="flat" w="0">
+                      <a:noFill/>
+                      <a:prstDash val="solid"/>
+                    </a:lnB>
+                    <a:solidFill>
+                      <a:srgbClr val="FFFFFF">
+                        <a:alpha val="0"/>
+                      </a:srgbClr>
+                    </a:solidFill>
+                  </a:tcPr>
+                </a:tc>
+              </a:tr>
+              <a:tr h="228600">
+                <a:tc>
+                  <a:txBody>
+                    <a:bodyPr/>
+                    <a:lstStyle/>
+                    <a:p>
+                      <a:pPr algn="l" marL="63500" marR="63500">
+                        <a:lnSpc>
+                          <a:spcPct val="100000"/>
+                        </a:lnSpc>
+                        <a:spcBef>
+                          <a:spcPts val="100"/>
+                        </a:spcBef>
+                        <a:spcAft>
+                          <a:spcPts val="100"/>
+                        </a:spcAft>
+                        <a:buNone/>
+                      </a:pPr>
+                      <a:rPr cap="none" sz="1100" i="0" b="0" u="none" strike="noStrike">
+                        <a:solidFill>
+                          <a:srgbClr val="000000">
+                            <a:alpha val="100000"/>
+                          </a:srgbClr>
+                        </a:solidFill>
+                        <a:latin typeface="DejaVu Sans"/>
+                        <a:cs typeface="DejaVu Sans"/>
+                        <a:ea typeface="DejaVu Sans"/>
+                        <a:sym typeface="DejaVu Sans"/>
+                      </a:rPr>
+                      <mc:AlternateContent xmlns:mc="http://schemas.openxmlformats.org/markup-compatibility/2006">
+                        <mc:Choice xmlns:a14="http://schemas.microsoft.com/office/drawing/2010/main" Requires="a14">
+                          <a14:m>
+                            <m:oMathPara xmlns:m="http://schemas.openxmlformats.org/officeDocument/2006/math">
+                              <m:oMathParaPr>
+                                <m:jc m:val="centerGroup"/>
+                              </m:oMathParaPr>
+                              <m:oMath xmlns:mml="http://www.w3.org/1998/Math/MathML">
+                                <m:f>
+                                  <m:fPr>
+                                    <m:type m:val="bar"/>
+                                  </m:fPr>
+                                  <m:num>
+                                    <m:r>
+                                      <m:t>d</m:t>
+                                    </m:r>
+                                    <m:r>
+                                      <m:rPr>
+                                        <m:nor/>
+                                      </m:rPr>
+                                      <m:t> </m:t>
+                                    </m:r>
+                                    <m:r>
+                                      <m:t>depot</m:t>
+                                    </m:r>
+                                  </m:num>
+                                  <m:den>
+                                    <m:r>
+                                      <m:t>dt</m:t>
+                                    </m:r>
+                                  </m:den>
+                                </m:f>
+                                <m:r>
+                                  <m:t>=−</m:t>
+                                </m:r>
+                                <m:r>
+                                  <m:t>ka</m:t>
+                                </m:r>
+                                <m:r>
+                                  <m:t>×</m:t>
+                                </m:r>
+                                <m:r>
+                                  <m:t>depot</m:t>
+                                </m:r>
+                              </m:oMath>
+                            </m:oMathPara>
+                          </a14:m>
+                        </mc:Choice>
+                      </mc:AlternateContent>
+                    </a:p>
+                  </a:txBody>
+                  <a:tcPr anchor="ctr" marB="12700" marT="12700" marR="0" marL="0">
+                    <a:lnL algn="ctr" cmpd="sng" cap="flat" w="0">
+                      <a:noFill/>
+                      <a:prstDash val="solid"/>
+                    </a:lnL>
+                    <a:lnR algn="ctr" cmpd="sng" cap="flat" w="0">
+                      <a:noFill/>
+                      <a:prstDash val="solid"/>
+                    </a:lnR>
+                    <a:lnT algn="ctr" cmpd="sng" cap="flat" w="0">
+                      <a:noFill/>
+                      <a:prstDash val="solid"/>
+                    </a:lnT>
+                    <a:lnB algn="ctr" cmpd="sng" cap="flat" w="0">
+                      <a:noFill/>
+                      <a:prstDash val="solid"/>
+                    </a:lnB>
+                    <a:solidFill>
+                      <a:srgbClr val="FFFFFF">
+                        <a:alpha val="0"/>
+                      </a:srgbClr>
+                    </a:solidFill>
+                  </a:tcPr>
+                </a:tc>
+              </a:tr>
+              <a:tr h="228600">
+                <a:tc>
+                  <a:txBody>
+                    <a:bodyPr/>
+                    <a:lstStyle/>
+                    <a:p>
+                      <a:pPr algn="l" marL="63500" marR="63500">
+                        <a:lnSpc>
+                          <a:spcPct val="100000"/>
+                        </a:lnSpc>
+                        <a:spcBef>
+                          <a:spcPts val="100"/>
+                        </a:spcBef>
+                        <a:spcAft>
+                          <a:spcPts val="100"/>
+                        </a:spcAft>
+                        <a:buNone/>
+                      </a:pPr>
+                      <a:rPr cap="none" sz="1100" i="0" b="0" u="none" strike="noStrike">
+                        <a:solidFill>
+                          <a:srgbClr val="000000">
+                            <a:alpha val="100000"/>
+                          </a:srgbClr>
+                        </a:solidFill>
+                        <a:latin typeface="DejaVu Sans"/>
+                        <a:cs typeface="DejaVu Sans"/>
+                        <a:ea typeface="DejaVu Sans"/>
+                        <a:sym typeface="DejaVu Sans"/>
+                      </a:rPr>
+                      <mc:AlternateContent xmlns:mc="http://schemas.openxmlformats.org/markup-compatibility/2006">
+                        <mc:Choice xmlns:a14="http://schemas.microsoft.com/office/drawing/2010/main" Requires="a14">
+                          <a14:m>
+                            <m:oMathPara xmlns:m="http://schemas.openxmlformats.org/officeDocument/2006/math">
+                              <m:oMathParaPr>
+                                <m:jc m:val="centerGroup"/>
+                              </m:oMathParaPr>
+                              <m:oMath xmlns:mml="http://www.w3.org/1998/Math/MathML">
+                                <m:f>
+                                  <m:fPr>
+                                    <m:type m:val="bar"/>
+                                  </m:fPr>
+                                  <m:num>
+                                    <m:r>
+                                      <m:t>d</m:t>
+                                    </m:r>
+                                    <m:r>
+                                      <m:rPr>
+                                        <m:nor/>
+                                      </m:rPr>
+                                      <m:t> </m:t>
+                                    </m:r>
+                                    <m:r>
+                                      <m:t>central</m:t>
+                                    </m:r>
+                                  </m:num>
+                                  <m:den>
+                                    <m:r>
+                                      <m:t>dt</m:t>
+                                    </m:r>
+                                  </m:den>
+                                </m:f>
+                                <m:r>
+                                  <m:t>=+</m:t>
+                                </m:r>
+                                <m:r>
+                                  <m:t>ka</m:t>
+                                </m:r>
+                                <m:r>
+                                  <m:t>×</m:t>
+                                </m:r>
+                                <m:r>
+                                  <m:t>depot</m:t>
+                                </m:r>
+                                <m:r>
+                                  <m:t>−</m:t>
+                                </m:r>
+                                <m:f>
+                                  <m:fPr>
+                                    <m:type m:val="bar"/>
+                                  </m:fPr>
+                                  <m:num>
+                                    <m:r>
+                                      <m:t>Cl</m:t>
+                                    </m:r>
+                                  </m:num>
+                                  <m:den>
+                                    <m:r>
+                                      <m:t>V</m:t>
+                                    </m:r>
+                                  </m:den>
+                                </m:f>
+                                <m:r>
+                                  <m:t>×</m:t>
+                                </m:r>
+                                <m:r>
+                                  <m:t>central</m:t>
+                                </m:r>
+                              </m:oMath>
+                            </m:oMathPara>
+                          </a14:m>
+                        </mc:Choice>
+                      </mc:AlternateContent>
+                    </a:p>
+                  </a:txBody>
+                  <a:tcPr anchor="ctr" marB="12700" marT="12700" marR="0" marL="0">
+                    <a:lnL algn="ctr" cmpd="sng" cap="flat" w="0">
+                      <a:noFill/>
+                      <a:prstDash val="solid"/>
+                    </a:lnL>
+                    <a:lnR algn="ctr" cmpd="sng" cap="flat" w="0">
+                      <a:noFill/>
+                      <a:prstDash val="solid"/>
+                    </a:lnR>
+                    <a:lnT algn="ctr" cmpd="sng" cap="flat" w="0">
+                      <a:noFill/>
+                      <a:prstDash val="solid"/>
+                    </a:lnT>
+                    <a:lnB algn="ctr" cmpd="sng" cap="flat" w="0">
+                      <a:noFill/>
+                      <a:prstDash val="solid"/>
+                    </a:lnB>
+                    <a:solidFill>
+                      <a:srgbClr val="FFFFFF">
+                        <a:alpha val="0"/>
+                      </a:srgbClr>
+                    </a:solidFill>
+                  </a:tcPr>
+                </a:tc>
+              </a:tr>
+              <a:tr h="228600">
+                <a:tc>
+                  <a:txBody>
+                    <a:bodyPr/>
+                    <a:lstStyle/>
+                    <a:p>
+                      <a:pPr algn="l" marL="63500" marR="63500">
+                        <a:lnSpc>
+                          <a:spcPct val="100000"/>
+                        </a:lnSpc>
+                        <a:spcBef>
+                          <a:spcPts val="100"/>
+                        </a:spcBef>
+                        <a:spcAft>
+                          <a:spcPts val="100"/>
+                        </a:spcAft>
+                        <a:buNone/>
+                      </a:pPr>
+                      <a:rPr cap="none" sz="1100" i="0" b="0" u="none" strike="noStrike">
+                        <a:solidFill>
+                          <a:srgbClr val="000000">
+                            <a:alpha val="100000"/>
+                          </a:srgbClr>
+                        </a:solidFill>
+                        <a:latin typeface="DejaVu Sans"/>
+                        <a:cs typeface="DejaVu Sans"/>
+                        <a:ea typeface="DejaVu Sans"/>
+                        <a:sym typeface="DejaVu Sans"/>
+                      </a:rPr>
+                      <mc:AlternateContent xmlns:mc="http://schemas.openxmlformats.org/markup-compatibility/2006">
+                        <mc:Choice xmlns:a14="http://schemas.microsoft.com/office/drawing/2010/main" Requires="a14">
+                          <a14:m>
+                            <m:oMathPara xmlns:m="http://schemas.openxmlformats.org/officeDocument/2006/math">
+                              <m:oMathParaPr>
+                                <m:jc m:val="centerGroup"/>
+                              </m:oMathParaPr>
+                              <m:oMath xmlns:mml="http://www.w3.org/1998/Math/MathML">
+                                <m:r>
+                                  <m:t>Cc</m:t>
+                                </m:r>
+                                <m:r>
+                                  <m:t>=</m:t>
+                                </m:r>
+                                <m:f>
+                                  <m:fPr>
+                                    <m:type m:val="bar"/>
+                                  </m:fPr>
+                                  <m:num>
+                                    <m:r>
+                                      <m:t>central</m:t>
+                                    </m:r>
+                                  </m:num>
+                                  <m:den>
+                                    <m:r>
+                                      <m:t>V</m:t>
+                                    </m:r>
+                                  </m:den>
+                                </m:f>
+                              </m:oMath>
+                            </m:oMathPara>
+                          </a14:m>
+                        </mc:Choice>
+                      </mc:AlternateContent>
+                    </a:p>
+                  </a:txBody>
+                  <a:tcPr anchor="ctr" marB="12700" marT="12700" marR="0" marL="0">
+                    <a:lnL algn="ctr" cmpd="sng" cap="flat" w="0">
+                      <a:noFill/>
+                      <a:prstDash val="solid"/>
+                    </a:lnL>
+                    <a:lnR algn="ctr" cmpd="sng" cap="flat" w="0">
+                      <a:noFill/>
+                      <a:prstDash val="solid"/>
+                    </a:lnR>
+                    <a:lnT algn="ctr" cmpd="sng" cap="flat" w="0">
+                      <a:noFill/>
+                      <a:prstDash val="solid"/>
+                    </a:lnT>
+                    <a:lnB algn="ctr" cmpd="sng" cap="flat" w="0">
+                      <a:noFill/>
+                      <a:prstDash val="solid"/>
+                    </a:lnB>
+                    <a:solidFill>
+                      <a:srgbClr val="FFFFFF">
+                        <a:alpha val="0"/>
+                      </a:srgbClr>
+                    </a:solidFill>
+                  </a:tcPr>
+                </a:tc>
+              </a:tr>
+              <a:tr h="228600">
+                <a:tc>
+                  <a:txBody>
+                    <a:bodyPr/>
+                    <a:lstStyle/>
+                    <a:p>
+                      <a:pPr algn="l" marL="63500" marR="63500">
+                        <a:lnSpc>
+                          <a:spcPct val="100000"/>
+                        </a:lnSpc>
+                        <a:spcBef>
+                          <a:spcPts val="100"/>
+                        </a:spcBef>
+                        <a:spcAft>
+                          <a:spcPts val="100"/>
+                        </a:spcAft>
+                        <a:buNone/>
+                      </a:pPr>
+                      <a:rPr cap="none" sz="1100" i="0" b="0" u="none" strike="noStrike">
+                        <a:solidFill>
+                          <a:srgbClr val="000000">
+                            <a:alpha val="100000"/>
+                          </a:srgbClr>
+                        </a:solidFill>
+                        <a:latin typeface="DejaVu Sans"/>
+                        <a:cs typeface="DejaVu Sans"/>
+                        <a:ea typeface="DejaVu Sans"/>
+                        <a:sym typeface="DejaVu Sans"/>
+                      </a:rPr>
+                      <mc:AlternateContent xmlns:mc="http://schemas.openxmlformats.org/markup-compatibility/2006">
+                        <mc:Choice xmlns:a14="http://schemas.microsoft.com/office/drawing/2010/main" Requires="a14">
+                          <a14:m>
+                            <m:oMathPara xmlns:m="http://schemas.openxmlformats.org/officeDocument/2006/math">
+                              <m:oMathParaPr>
+                                <m:jc m:val="centerGroup"/>
+                              </m:oMathParaPr>
+                              <m:oMath xmlns:mml="http://www.w3.org/1998/Math/MathML">
+                                <m:r>
+                                  <m:t>CONC</m:t>
+                                </m:r>
+                                <m:r>
+                                  <m:t>=</m:t>
+                                </m:r>
+                                <m:r>
+                                  <m:t>Cc</m:t>
+                                </m:r>
+                              </m:oMath>
+                            </m:oMathPara>
+                          </a14:m>
+                        </mc:Choice>
+                      </mc:AlternateContent>
+                    </a:p>
+                  </a:txBody>
+                  <a:tcPr anchor="ctr" marB="12700" marT="12700" marR="0" marL="0">
+                    <a:lnL algn="ctr" cmpd="sng" cap="flat" w="0">
+                      <a:noFill/>
+                      <a:prstDash val="solid"/>
+                    </a:lnL>
+                    <a:lnR algn="ctr" cmpd="sng" cap="flat" w="0">
+                      <a:noFill/>
+                      <a:prstDash val="solid"/>
+                    </a:lnR>
+                    <a:lnT algn="ctr" cmpd="sng" cap="flat" w="0">
+                      <a:noFill/>
+                      <a:prstDash val="solid"/>
+                    </a:lnT>
+                    <a:lnB algn="ctr" cmpd="sng" cap="flat" w="0">
+                      <a:noFill/>
+                      <a:prstDash val="solid"/>
+                    </a:lnB>
+                    <a:solidFill>
+                      <a:srgbClr val="FFFFFF">
+                        <a:alpha val="0"/>
+                      </a:srgbClr>
+                    </a:solidFill>
+                  </a:tcPr>
+                </a:tc>
+              </a:tr>
+              <a:tr h="228600">
+                <a:tc>
+                  <a:txBody>
+                    <a:bodyPr/>
+                    <a:lstStyle/>
+                    <a:p>
+                      <a:pPr algn="l" marL="63500" marR="63500">
+                        <a:lnSpc>
+                          <a:spcPct val="100000"/>
+                        </a:lnSpc>
+                        <a:spcBef>
+                          <a:spcPts val="100"/>
+                        </a:spcBef>
+                        <a:spcAft>
+                          <a:spcPts val="100"/>
+                        </a:spcAft>
+                        <a:buNone/>
+                      </a:pPr>
+                      <a:rPr cap="none" sz="1100" i="0" b="0" u="none" strike="noStrike">
+                        <a:solidFill>
+                          <a:srgbClr val="000000">
+                            <a:alpha val="100000"/>
+                          </a:srgbClr>
+                        </a:solidFill>
+                        <a:latin typeface="DejaVu Sans"/>
+                        <a:cs typeface="DejaVu Sans"/>
+                        <a:ea typeface="DejaVu Sans"/>
+                        <a:sym typeface="DejaVu Sans"/>
+                      </a:rPr>
+                      <mc:AlternateContent xmlns:mc="http://schemas.openxmlformats.org/markup-compatibility/2006">
+                        <mc:Choice xmlns:a14="http://schemas.microsoft.com/office/drawing/2010/main" Requires="a14">
+                          <a14:m>
+                            <m:oMathPara xmlns:m="http://schemas.openxmlformats.org/officeDocument/2006/math">
+                              <m:oMathParaPr>
+                                <m:jc m:val="centerGroup"/>
+                              </m:oMathParaPr>
+                              <m:oMath xmlns:mml="http://www.w3.org/1998/Math/MathML">
+                                <m:r>
+                                  <m:t>CONC</m:t>
+                                </m:r>
+                                <m:r>
+                                  <m:t>∼add(a)+prop(b)+combined1()</m:t>
+                                </m:r>
+                              </m:oMath>
+                            </m:oMathPara>
+                          </a14:m>
+                        </mc:Choice>
+                      </mc:AlternateContent>
+                    </a:p>
+                  </a:txBody>
+                  <a:tcPr anchor="ctr" marB="12700" marT="12700" marR="0" marL="0">
+                    <a:lnL algn="ctr" cmpd="sng" cap="flat" w="0">
+                      <a:noFill/>
+                      <a:prstDash val="solid"/>
+                    </a:lnL>
+                    <a:lnR algn="ctr" cmpd="sng" cap="flat" w="0">
+                      <a:noFill/>
+                      <a:prstDash val="solid"/>
+                    </a:lnR>
+                    <a:lnT algn="ctr" cmpd="sng" cap="flat" w="0">
+                      <a:noFill/>
+                      <a:prstDash val="solid"/>
+                    </a:lnT>
+                    <a:lnB algn="ctr" cmpd="sng" cap="flat" w="0">
+                      <a:noFill/>
+                      <a:prstDash val="solid"/>
+                    </a:lnB>
+                    <a:solidFill>
+                      <a:srgbClr val="FFFFFF">
+                        <a:alpha val="0"/>
+                      </a:srgbClr>
+                    </a:solidFill>
+                  </a:tcPr>
+                </a:tc>
+              </a:tr>
+            </a:tbl>
+          </a:graphicData>
+        </a:graphic>
+      </p:graphicFrame>
+    </p:spTree>
+  </p:cSld>
+  <p:clrMapOvr>
+    <a:masterClrMapping/>
+  </p:clrMapOvr>
+</p:sld>
+</file>
+
+<file path=ppt/slides/slide3.xml><?xml version="1.0" encoding="utf-8"?>
+<p:sld xmlns:a="http://schemas.openxmlformats.org/drawingml/2006/main" xmlns:r="http://schemas.openxmlformats.org/officeDocument/2006/relationships" xmlns:p="http://schemas.openxmlformats.org/presentationml/2006/main">
+  <p:cSld>
+    <p:spTree>
+      <p:nvGrpSpPr>
+        <p:cNvPr id="1" name=""/>
+        <p:cNvGrpSpPr/>
+        <p:nvPr/>
+      </p:nvGrpSpPr>
+      <p:grpSpPr>
+        <a:xfrm>
+          <a:off x="0" y="0"/>
+          <a:ext cx="0" cy="0"/>
+          <a:chOff x="0" y="0"/>
+          <a:chExt cx="0" cy="0"/>
+        </a:xfrm>
+      </p:grpSpPr>
+      <p:sp>
+        <p:nvSpPr>
+          <p:cNvPr id="2" name="Title 1"/>
+          <p:cNvSpPr>
+            <a:spLocks noGrp="1"/>
+          </p:cNvSpPr>
+          <p:nvPr>
+            <p:ph type="title"/>
+          </p:nvPr>
+        </p:nvSpPr>
+        <p:spPr>
+          <a:xfrm>
+            <a:off x="623392" y="113388"/>
+            <a:ext cx="10945216" cy="985909"/>
+          </a:xfrm>
+        </p:spPr>
+        <p:txBody>
+          <a:bodyPr/>
+          <a:lstStyle/>
+          <a:p>
+            <a:r>
+              <a:rPr/>
               <a:t>Parameter Estimates</a:t>
             </a:r>
           </a:p>
@@ -6270,7 +7406,7 @@
 </p:sld>
 </file>
 
-<file path=ppt/slides/slide2.xml><?xml version="1.0" encoding="utf-8"?>
+<file path=ppt/slides/slide4.xml><?xml version="1.0" encoding="utf-8"?>
 <p:sld xmlns:a="http://schemas.openxmlformats.org/drawingml/2006/main" xmlns:r="http://schemas.openxmlformats.org/officeDocument/2006/relationships" xmlns:p="http://schemas.openxmlformats.org/presentationml/2006/main">
   <p:cSld>
     <p:spTree>
@@ -6348,7 +7484,7 @@
 </p:sld>
 </file>
 
-<file path=ppt/slides/slide3.xml><?xml version="1.0" encoding="utf-8"?>
+<file path=ppt/slides/slide5.xml><?xml version="1.0" encoding="utf-8"?>
 <p:sld xmlns:a="http://schemas.openxmlformats.org/drawingml/2006/main" xmlns:r="http://schemas.openxmlformats.org/officeDocument/2006/relationships" xmlns:p="http://schemas.openxmlformats.org/presentationml/2006/main">
   <p:cSld>
     <p:spTree>
@@ -6426,7 +7562,7 @@
 </p:sld>
 </file>
 
-<file path=ppt/slides/slide4.xml><?xml version="1.0" encoding="utf-8"?>
+<file path=ppt/slides/slide6.xml><?xml version="1.0" encoding="utf-8"?>
 <p:sld xmlns:a="http://schemas.openxmlformats.org/drawingml/2006/main" xmlns:r="http://schemas.openxmlformats.org/officeDocument/2006/relationships" xmlns:p="http://schemas.openxmlformats.org/presentationml/2006/main">
   <p:cSld>
     <p:spTree>

</xml_diff>